<commit_message>
Update SMART ATTENDANCE MONITORING to include team member Ashwathraj (2117230070017)
</commit_message>
<xml_diff>
--- a/SMART_ATTENDANCE_MONITORING.pptx
+++ b/SMART_ATTENDANCE_MONITORING.pptx
@@ -522,7 +522,7 @@
           </a:p>
           <a:p>
             <a:r>
-              <a:t>'Good morning respected staff and panel members. I am Dhanush M N, Register Number 2117230070028, from the Department of Artificial Intelligence and Data Science. Today, I am presenting my First Project Review on 'SMART ATTENDANCE MONITORING SYSTEM'. This project automates daily classroom and office attendance using AI face recognition, eliminating manual roll calls, saving classroom time, and completely preventing proxy attendance.'</a:t>
+              <a:t>'Good morning respected staff and panel members. We are Dhanush M N and Ashwathraj, from the Department of Artificial Intelligence and Data Science. Today, we are presenting our First Project Review on 'SMART ATTENDANCE MONITORING SYSTEM'. This project automates daily classroom and office attendance using AI face recognition, eliminating manual roll calls, saving classroom time, and completely preventing proxy attendance.'</a:t>
             </a:r>
           </a:p>
         </p:txBody>
@@ -5088,7 +5088,7 @@
           <a:p>
             <a:pPr>
               <a:spcAft>
-                <a:spcPts val="1200"/>
+                <a:spcPts val="800"/>
               </a:spcAft>
               <a:defRPr sz="1300" b="1">
                 <a:solidFill>
@@ -5097,42 +5097,42 @@
               </a:defRPr>
             </a:pPr>
             <a:r>
-              <a:t>👤  PROJECT SUBMITTED BY</a:t>
-            </a:r>
-          </a:p>
-          <a:p>
-            <a:pPr>
-              <a:spcAft>
-                <a:spcPts val="400"/>
-              </a:spcAft>
-              <a:defRPr sz="2000" b="1">
+              <a:t>👥  PROJECT MEMBERS</a:t>
+            </a:r>
+          </a:p>
+          <a:p>
+            <a:pPr>
+              <a:spcAft>
+                <a:spcPts val="600"/>
+              </a:spcAft>
+              <a:defRPr sz="1400" b="1">
                 <a:solidFill>
                   <a:srgbClr val="0F172A"/>
                 </a:solidFill>
               </a:defRPr>
             </a:pPr>
             <a:r>
-              <a:t>DHANUSH M N</a:t>
-            </a:r>
-          </a:p>
-          <a:p>
-            <a:pPr>
-              <a:spcAft>
-                <a:spcPts val="1000"/>
+              <a:t>DHANUSH M N   (2117230070028)</a:t>
+            </a:r>
+          </a:p>
+          <a:p>
+            <a:pPr>
+              <a:spcAft>
+                <a:spcPts val="600"/>
               </a:spcAft>
               <a:defRPr sz="1400" b="1">
                 <a:solidFill>
-                  <a:srgbClr val="1A56DB"/>
-                </a:solidFill>
-              </a:defRPr>
-            </a:pPr>
-            <a:r>
-              <a:t>Register Number: 2117230070028</a:t>
-            </a:r>
-          </a:p>
-          <a:p>
-            <a:pPr>
-              <a:defRPr sz="1150">
+                  <a:srgbClr val="0F172A"/>
+                </a:solidFill>
+              </a:defRPr>
+            </a:pPr>
+            <a:r>
+              <a:t>ASHWATHRAJ   (2117230070017)</a:t>
+            </a:r>
+          </a:p>
+          <a:p>
+            <a:pPr>
+              <a:defRPr sz="1100">
                 <a:solidFill>
                   <a:srgbClr val="1E293B"/>
                 </a:solidFill>

</xml_diff>

<commit_message>
Add complete Smart Attendance Monitoring Presentation (PPTX) and Base Paper Review Report (PDF & DOCX) for Dhanush MN, Ashwathraj, Athish R
</commit_message>
<xml_diff>
--- a/SMART_ATTENDANCE_MONITORING.pptx
+++ b/SMART_ATTENDANCE_MONITORING.pptx
@@ -522,7 +522,7 @@
           </a:p>
           <a:p>
             <a:r>
-              <a:t>'Good morning respected staff and panel members. We are Dhanush M N and Ashwathraj, from the Department of Artificial Intelligence and Data Science. Today, we are presenting our First Project Review on 'SMART ATTENDANCE MONITORING SYSTEM'. This project automates daily classroom and office attendance using AI face recognition, eliminating manual roll calls, saving classroom time, and completely preventing proxy attendance.'</a:t>
+              <a:t>'Good morning respected staff and panel members. We are Dhanush M N, Ashwathraj, and Athish R, from the Department of Artificial Intelligence and Data Science. Today, we are presenting our First Project Review on 'SMART ATTENDANCE MONITORING SYSTEM'. This project automates daily classroom and office attendance using AI face recognition, eliminating manual roll calls, saving classroom time, and completely preventing proxy attendance.'</a:t>
             </a:r>
           </a:p>
         </p:txBody>
@@ -4819,6 +4819,41 @@
         </p:nvSpPr>
         <p:spPr>
           <a:xfrm>
+            <a:off x="731520" y="6492240"/>
+            <a:ext cx="10728655" cy="320040"/>
+          </a:xfrm>
+          <a:prstGeom prst="rect">
+            <a:avLst/>
+          </a:prstGeom>
+          <a:noFill/>
+        </p:spPr>
+        <p:txBody>
+          <a:bodyPr wrap="none">
+            <a:spAutoFit/>
+          </a:bodyPr>
+          <a:lstStyle/>
+          <a:p>
+            <a:pPr>
+              <a:defRPr sz="950">
+                <a:solidFill>
+                  <a:srgbClr val="64748B"/>
+                </a:solidFill>
+              </a:defRPr>
+            </a:pPr>
+            <a:r>
+              <a:t>Dept of AI &amp; DS | RIT | Project Review - 1 | Team: DHANUSH MN (2117230070028), ASHWATHRAJ (2117230070017), ATHISH R (2117230070020)</a:t>
+            </a:r>
+          </a:p>
+        </p:txBody>
+      </p:sp>
+      <p:sp>
+        <p:nvSpPr>
+          <p:cNvPr id="7" name="TextBox 6"/>
+          <p:cNvSpPr txBox="1"/>
+          <p:nvPr/>
+        </p:nvSpPr>
+        <p:spPr>
+          <a:xfrm>
             <a:off x="731520" y="1051560"/>
             <a:ext cx="10728655" cy="2103120"/>
           </a:xfrm>
@@ -4849,7 +4884,10 @@
           </a:p>
           <a:p>
             <a:pPr>
-              <a:defRPr sz="1450">
+              <a:spcAft>
+                <a:spcPts val="400"/>
+              </a:spcAft>
+              <a:defRPr sz="1350">
                 <a:solidFill>
                   <a:srgbClr val="64748B"/>
                 </a:solidFill>
@@ -4859,11 +4897,23 @@
               <a:t>An Automated Contactless Face Recognition Attendance Engine using Deep Learning, Real-Time Video Analytics, and Cloud Database Integration</a:t>
             </a:r>
           </a:p>
-        </p:txBody>
-      </p:sp>
-      <p:sp>
-        <p:nvSpPr>
-          <p:cNvPr id="7" name="Rounded Rectangle 6"/>
+          <a:p>
+            <a:pPr>
+              <a:defRPr sz="1200" b="1">
+                <a:solidFill>
+                  <a:srgbClr val="1A56DB"/>
+                </a:solidFill>
+              </a:defRPr>
+            </a:pPr>
+            <a:r>
+              <a:t>Presented by: DHANUSH MN (2117230070028)  •  ASHWATHRAJ (2117230070017)  •  ATHISH R (2117230070020)</a:t>
+            </a:r>
+          </a:p>
+        </p:txBody>
+      </p:sp>
+      <p:sp>
+        <p:nvSpPr>
+          <p:cNvPr id="8" name="Rounded Rectangle 7"/>
           <p:cNvSpPr/>
           <p:nvPr/>
         </p:nvSpPr>
@@ -4908,7 +4958,7 @@
       </p:sp>
       <p:sp>
         <p:nvSpPr>
-          <p:cNvPr id="8" name="TextBox 7"/>
+          <p:cNvPr id="9" name="TextBox 8"/>
           <p:cNvSpPr txBox="1"/>
           <p:nvPr/>
         </p:nvSpPr>
@@ -5021,7 +5071,7 @@
       </p:sp>
       <p:sp>
         <p:nvSpPr>
-          <p:cNvPr id="9" name="Rounded Rectangle 8"/>
+          <p:cNvPr id="10" name="Rounded Rectangle 9"/>
           <p:cNvSpPr/>
           <p:nvPr/>
         </p:nvSpPr>
@@ -5066,7 +5116,7 @@
       </p:sp>
       <p:sp>
         <p:nvSpPr>
-          <p:cNvPr id="10" name="TextBox 9"/>
+          <p:cNvPr id="11" name="TextBox 10"/>
           <p:cNvSpPr txBox="1"/>
           <p:nvPr/>
         </p:nvSpPr>
@@ -5103,24 +5153,24 @@
           <a:p>
             <a:pPr>
               <a:spcAft>
-                <a:spcPts val="600"/>
-              </a:spcAft>
-              <a:defRPr sz="1400" b="1">
+                <a:spcPts val="400"/>
+              </a:spcAft>
+              <a:defRPr sz="1300" b="1">
                 <a:solidFill>
                   <a:srgbClr val="0F172A"/>
                 </a:solidFill>
               </a:defRPr>
             </a:pPr>
             <a:r>
-              <a:t>DHANUSH M N   (2117230070028)</a:t>
-            </a:r>
-          </a:p>
-          <a:p>
-            <a:pPr>
-              <a:spcAft>
-                <a:spcPts val="600"/>
-              </a:spcAft>
-              <a:defRPr sz="1400" b="1">
+              <a:t>DHANUSH MN   (2117230070028)</a:t>
+            </a:r>
+          </a:p>
+          <a:p>
+            <a:pPr>
+              <a:spcAft>
+                <a:spcPts val="400"/>
+              </a:spcAft>
+              <a:defRPr sz="1300" b="1">
                 <a:solidFill>
                   <a:srgbClr val="0F172A"/>
                 </a:solidFill>
@@ -5132,18 +5182,29 @@
           </a:p>
           <a:p>
             <a:pPr>
-              <a:defRPr sz="1100">
-                <a:solidFill>
-                  <a:srgbClr val="1E293B"/>
-                </a:solidFill>
-              </a:defRPr>
-            </a:pPr>
-            <a:r>
-              <a:t>B.Tech Artificial Intelligence and Data Science</a:t>
-            </a:r>
-            <a:br/>
-            <a:r>
-              <a:t>First Project Review Presentation</a:t>
+              <a:spcAft>
+                <a:spcPts val="400"/>
+              </a:spcAft>
+              <a:defRPr sz="1300" b="1">
+                <a:solidFill>
+                  <a:srgbClr val="0F172A"/>
+                </a:solidFill>
+              </a:defRPr>
+            </a:pPr>
+            <a:r>
+              <a:t>ATHISH R   (2117230070020)</a:t>
+            </a:r>
+          </a:p>
+          <a:p>
+            <a:pPr>
+              <a:defRPr sz="1050">
+                <a:solidFill>
+                  <a:srgbClr val="64748B"/>
+                </a:solidFill>
+              </a:defRPr>
+            </a:pPr>
+            <a:r>
+              <a:t>B.Tech Artificial Intelligence &amp; Data Science | First Review</a:t>
             </a:r>
           </a:p>
         </p:txBody>
@@ -5332,6 +5393,41 @@
         </p:nvSpPr>
         <p:spPr>
           <a:xfrm>
+            <a:off x="731520" y="6492240"/>
+            <a:ext cx="10728655" cy="320040"/>
+          </a:xfrm>
+          <a:prstGeom prst="rect">
+            <a:avLst/>
+          </a:prstGeom>
+          <a:noFill/>
+        </p:spPr>
+        <p:txBody>
+          <a:bodyPr wrap="none">
+            <a:spAutoFit/>
+          </a:bodyPr>
+          <a:lstStyle/>
+          <a:p>
+            <a:pPr>
+              <a:defRPr sz="950">
+                <a:solidFill>
+                  <a:srgbClr val="64748B"/>
+                </a:solidFill>
+              </a:defRPr>
+            </a:pPr>
+            <a:r>
+              <a:t>Dept of AI &amp; DS | RIT | Project Review - 1 | Team: DHANUSH MN (2117230070028), ASHWATHRAJ (2117230070017), ATHISH R (2117230070020)</a:t>
+            </a:r>
+          </a:p>
+        </p:txBody>
+      </p:sp>
+      <p:sp>
+        <p:nvSpPr>
+          <p:cNvPr id="7" name="TextBox 6"/>
+          <p:cNvSpPr txBox="1"/>
+          <p:nvPr/>
+        </p:nvSpPr>
+        <p:spPr>
+          <a:xfrm>
             <a:off x="731520" y="658368"/>
             <a:ext cx="10728655" cy="685800"/>
           </a:xfrm>
@@ -5373,7 +5469,7 @@
       </p:sp>
       <p:sp>
         <p:nvSpPr>
-          <p:cNvPr id="7" name="Rounded Rectangle 6"/>
+          <p:cNvPr id="8" name="Rounded Rectangle 7"/>
           <p:cNvSpPr/>
           <p:nvPr/>
         </p:nvSpPr>
@@ -5418,7 +5514,7 @@
       </p:sp>
       <p:sp>
         <p:nvSpPr>
-          <p:cNvPr id="8" name="TextBox 7"/>
+          <p:cNvPr id="9" name="TextBox 8"/>
           <p:cNvSpPr txBox="1"/>
           <p:nvPr/>
         </p:nvSpPr>
@@ -5516,7 +5612,7 @@
       </p:sp>
       <p:sp>
         <p:nvSpPr>
-          <p:cNvPr id="9" name="Rounded Rectangle 8"/>
+          <p:cNvPr id="10" name="Rounded Rectangle 9"/>
           <p:cNvSpPr/>
           <p:nvPr/>
         </p:nvSpPr>
@@ -5561,7 +5657,7 @@
       </p:sp>
       <p:sp>
         <p:nvSpPr>
-          <p:cNvPr id="10" name="TextBox 9"/>
+          <p:cNvPr id="11" name="TextBox 10"/>
           <p:cNvSpPr txBox="1"/>
           <p:nvPr/>
         </p:nvSpPr>
@@ -5841,6 +5937,41 @@
         </p:nvSpPr>
         <p:spPr>
           <a:xfrm>
+            <a:off x="731520" y="6492240"/>
+            <a:ext cx="10728655" cy="320040"/>
+          </a:xfrm>
+          <a:prstGeom prst="rect">
+            <a:avLst/>
+          </a:prstGeom>
+          <a:noFill/>
+        </p:spPr>
+        <p:txBody>
+          <a:bodyPr wrap="none">
+            <a:spAutoFit/>
+          </a:bodyPr>
+          <a:lstStyle/>
+          <a:p>
+            <a:pPr>
+              <a:defRPr sz="950">
+                <a:solidFill>
+                  <a:srgbClr val="64748B"/>
+                </a:solidFill>
+              </a:defRPr>
+            </a:pPr>
+            <a:r>
+              <a:t>Dept of AI &amp; DS | RIT | Project Review - 1 | Team: DHANUSH MN (2117230070028), ASHWATHRAJ (2117230070017), ATHISH R (2117230070020)</a:t>
+            </a:r>
+          </a:p>
+        </p:txBody>
+      </p:sp>
+      <p:sp>
+        <p:nvSpPr>
+          <p:cNvPr id="7" name="TextBox 6"/>
+          <p:cNvSpPr txBox="1"/>
+          <p:nvPr/>
+        </p:nvSpPr>
+        <p:spPr>
+          <a:xfrm>
             <a:off x="731520" y="658368"/>
             <a:ext cx="10728655" cy="685800"/>
           </a:xfrm>
@@ -5882,7 +6013,7 @@
       </p:sp>
       <p:sp>
         <p:nvSpPr>
-          <p:cNvPr id="7" name="Rounded Rectangle 6"/>
+          <p:cNvPr id="8" name="Rounded Rectangle 7"/>
           <p:cNvSpPr/>
           <p:nvPr/>
         </p:nvSpPr>
@@ -5927,7 +6058,7 @@
       </p:sp>
       <p:sp>
         <p:nvSpPr>
-          <p:cNvPr id="8" name="TextBox 7"/>
+          <p:cNvPr id="9" name="TextBox 8"/>
           <p:cNvSpPr txBox="1"/>
           <p:nvPr/>
         </p:nvSpPr>
@@ -5992,7 +6123,7 @@
       </p:sp>
       <p:sp>
         <p:nvSpPr>
-          <p:cNvPr id="9" name="Rounded Rectangle 8"/>
+          <p:cNvPr id="10" name="Rounded Rectangle 9"/>
           <p:cNvSpPr/>
           <p:nvPr/>
         </p:nvSpPr>
@@ -6037,7 +6168,7 @@
       </p:sp>
       <p:sp>
         <p:nvSpPr>
-          <p:cNvPr id="10" name="TextBox 9"/>
+          <p:cNvPr id="11" name="TextBox 10"/>
           <p:cNvSpPr txBox="1"/>
           <p:nvPr/>
         </p:nvSpPr>
@@ -6102,7 +6233,7 @@
       </p:sp>
       <p:sp>
         <p:nvSpPr>
-          <p:cNvPr id="11" name="Rounded Rectangle 10"/>
+          <p:cNvPr id="12" name="Rounded Rectangle 11"/>
           <p:cNvSpPr/>
           <p:nvPr/>
         </p:nvSpPr>
@@ -6147,7 +6278,7 @@
       </p:sp>
       <p:sp>
         <p:nvSpPr>
-          <p:cNvPr id="12" name="TextBox 11"/>
+          <p:cNvPr id="13" name="TextBox 12"/>
           <p:cNvSpPr txBox="1"/>
           <p:nvPr/>
         </p:nvSpPr>
@@ -6212,7 +6343,7 @@
       </p:sp>
       <p:sp>
         <p:nvSpPr>
-          <p:cNvPr id="13" name="Rounded Rectangle 12"/>
+          <p:cNvPr id="14" name="Rounded Rectangle 13"/>
           <p:cNvSpPr/>
           <p:nvPr/>
         </p:nvSpPr>
@@ -6257,7 +6388,7 @@
       </p:sp>
       <p:sp>
         <p:nvSpPr>
-          <p:cNvPr id="14" name="TextBox 13"/>
+          <p:cNvPr id="15" name="TextBox 14"/>
           <p:cNvSpPr txBox="1"/>
           <p:nvPr/>
         </p:nvSpPr>
@@ -6322,7 +6453,7 @@
       </p:sp>
       <p:sp>
         <p:nvSpPr>
-          <p:cNvPr id="15" name="Rounded Rectangle 14"/>
+          <p:cNvPr id="16" name="Rounded Rectangle 15"/>
           <p:cNvSpPr/>
           <p:nvPr/>
         </p:nvSpPr>
@@ -6367,7 +6498,7 @@
       </p:sp>
       <p:sp>
         <p:nvSpPr>
-          <p:cNvPr id="16" name="TextBox 15"/>
+          <p:cNvPr id="17" name="TextBox 16"/>
           <p:cNvSpPr txBox="1"/>
           <p:nvPr/>
         </p:nvSpPr>
@@ -6432,7 +6563,7 @@
       </p:sp>
       <p:sp>
         <p:nvSpPr>
-          <p:cNvPr id="17" name="Rounded Rectangle 16"/>
+          <p:cNvPr id="18" name="Rounded Rectangle 17"/>
           <p:cNvSpPr/>
           <p:nvPr/>
         </p:nvSpPr>
@@ -6477,7 +6608,7 @@
       </p:sp>
       <p:sp>
         <p:nvSpPr>
-          <p:cNvPr id="18" name="TextBox 17"/>
+          <p:cNvPr id="19" name="TextBox 18"/>
           <p:cNvSpPr txBox="1"/>
           <p:nvPr/>
         </p:nvSpPr>
@@ -6724,6 +6855,41 @@
         </p:nvSpPr>
         <p:spPr>
           <a:xfrm>
+            <a:off x="731520" y="6492240"/>
+            <a:ext cx="10728655" cy="320040"/>
+          </a:xfrm>
+          <a:prstGeom prst="rect">
+            <a:avLst/>
+          </a:prstGeom>
+          <a:noFill/>
+        </p:spPr>
+        <p:txBody>
+          <a:bodyPr wrap="none">
+            <a:spAutoFit/>
+          </a:bodyPr>
+          <a:lstStyle/>
+          <a:p>
+            <a:pPr>
+              <a:defRPr sz="950">
+                <a:solidFill>
+                  <a:srgbClr val="64748B"/>
+                </a:solidFill>
+              </a:defRPr>
+            </a:pPr>
+            <a:r>
+              <a:t>Dept of AI &amp; DS | RIT | Project Review - 1 | Team: DHANUSH MN (2117230070028), ASHWATHRAJ (2117230070017), ATHISH R (2117230070020)</a:t>
+            </a:r>
+          </a:p>
+        </p:txBody>
+      </p:sp>
+      <p:sp>
+        <p:nvSpPr>
+          <p:cNvPr id="7" name="TextBox 6"/>
+          <p:cNvSpPr txBox="1"/>
+          <p:nvPr/>
+        </p:nvSpPr>
+        <p:spPr>
+          <a:xfrm>
             <a:off x="731520" y="658368"/>
             <a:ext cx="10728655" cy="685800"/>
           </a:xfrm>
@@ -6765,7 +6931,7 @@
       </p:sp>
       <p:sp>
         <p:nvSpPr>
-          <p:cNvPr id="7" name="Rounded Rectangle 6"/>
+          <p:cNvPr id="8" name="Rounded Rectangle 7"/>
           <p:cNvSpPr/>
           <p:nvPr/>
         </p:nvSpPr>
@@ -6810,7 +6976,7 @@
       </p:sp>
       <p:sp>
         <p:nvSpPr>
-          <p:cNvPr id="8" name="TextBox 7"/>
+          <p:cNvPr id="9" name="TextBox 8"/>
           <p:cNvSpPr txBox="1"/>
           <p:nvPr/>
         </p:nvSpPr>
@@ -6908,7 +7074,7 @@
       </p:sp>
       <p:sp>
         <p:nvSpPr>
-          <p:cNvPr id="9" name="Rounded Rectangle 8"/>
+          <p:cNvPr id="10" name="Rounded Rectangle 9"/>
           <p:cNvSpPr/>
           <p:nvPr/>
         </p:nvSpPr>
@@ -6953,7 +7119,7 @@
       </p:sp>
       <p:sp>
         <p:nvSpPr>
-          <p:cNvPr id="10" name="TextBox 9"/>
+          <p:cNvPr id="11" name="TextBox 10"/>
           <p:cNvSpPr txBox="1"/>
           <p:nvPr/>
         </p:nvSpPr>
@@ -7051,7 +7217,7 @@
       </p:sp>
       <p:sp>
         <p:nvSpPr>
-          <p:cNvPr id="11" name="Rounded Rectangle 10"/>
+          <p:cNvPr id="12" name="Rounded Rectangle 11"/>
           <p:cNvSpPr/>
           <p:nvPr/>
         </p:nvSpPr>
@@ -7096,7 +7262,7 @@
       </p:sp>
       <p:sp>
         <p:nvSpPr>
-          <p:cNvPr id="12" name="TextBox 11"/>
+          <p:cNvPr id="13" name="TextBox 12"/>
           <p:cNvSpPr txBox="1"/>
           <p:nvPr/>
         </p:nvSpPr>
@@ -7194,7 +7360,7 @@
       </p:sp>
       <p:sp>
         <p:nvSpPr>
-          <p:cNvPr id="13" name="Rounded Rectangle 12"/>
+          <p:cNvPr id="14" name="Rounded Rectangle 13"/>
           <p:cNvSpPr/>
           <p:nvPr/>
         </p:nvSpPr>
@@ -7239,7 +7405,7 @@
       </p:sp>
       <p:sp>
         <p:nvSpPr>
-          <p:cNvPr id="14" name="TextBox 13"/>
+          <p:cNvPr id="15" name="TextBox 14"/>
           <p:cNvSpPr txBox="1"/>
           <p:nvPr/>
         </p:nvSpPr>
@@ -7519,6 +7685,41 @@
         </p:nvSpPr>
         <p:spPr>
           <a:xfrm>
+            <a:off x="731520" y="6492240"/>
+            <a:ext cx="10728655" cy="320040"/>
+          </a:xfrm>
+          <a:prstGeom prst="rect">
+            <a:avLst/>
+          </a:prstGeom>
+          <a:noFill/>
+        </p:spPr>
+        <p:txBody>
+          <a:bodyPr wrap="none">
+            <a:spAutoFit/>
+          </a:bodyPr>
+          <a:lstStyle/>
+          <a:p>
+            <a:pPr>
+              <a:defRPr sz="950">
+                <a:solidFill>
+                  <a:srgbClr val="64748B"/>
+                </a:solidFill>
+              </a:defRPr>
+            </a:pPr>
+            <a:r>
+              <a:t>Dept of AI &amp; DS | RIT | Project Review - 1 | Team: DHANUSH MN (2117230070028), ASHWATHRAJ (2117230070017), ATHISH R (2117230070020)</a:t>
+            </a:r>
+          </a:p>
+        </p:txBody>
+      </p:sp>
+      <p:sp>
+        <p:nvSpPr>
+          <p:cNvPr id="7" name="TextBox 6"/>
+          <p:cNvSpPr txBox="1"/>
+          <p:nvPr/>
+        </p:nvSpPr>
+        <p:spPr>
+          <a:xfrm>
             <a:off x="731520" y="658368"/>
             <a:ext cx="10728655" cy="685800"/>
           </a:xfrm>
@@ -7560,7 +7761,7 @@
       </p:sp>
       <p:sp>
         <p:nvSpPr>
-          <p:cNvPr id="7" name="Rounded Rectangle 6"/>
+          <p:cNvPr id="8" name="Rounded Rectangle 7"/>
           <p:cNvSpPr/>
           <p:nvPr/>
         </p:nvSpPr>
@@ -7605,7 +7806,7 @@
       </p:sp>
       <p:sp>
         <p:nvSpPr>
-          <p:cNvPr id="8" name="TextBox 7"/>
+          <p:cNvPr id="9" name="TextBox 8"/>
           <p:cNvSpPr txBox="1"/>
           <p:nvPr/>
         </p:nvSpPr>
@@ -7703,7 +7904,7 @@
       </p:sp>
       <p:sp>
         <p:nvSpPr>
-          <p:cNvPr id="9" name="Rounded Rectangle 8"/>
+          <p:cNvPr id="10" name="Rounded Rectangle 9"/>
           <p:cNvSpPr/>
           <p:nvPr/>
         </p:nvSpPr>
@@ -7748,7 +7949,7 @@
       </p:sp>
       <p:sp>
         <p:nvSpPr>
-          <p:cNvPr id="10" name="TextBox 9"/>
+          <p:cNvPr id="11" name="TextBox 10"/>
           <p:cNvSpPr txBox="1"/>
           <p:nvPr/>
         </p:nvSpPr>
@@ -7846,7 +8047,7 @@
       </p:sp>
       <p:sp>
         <p:nvSpPr>
-          <p:cNvPr id="11" name="Rounded Rectangle 10"/>
+          <p:cNvPr id="12" name="Rounded Rectangle 11"/>
           <p:cNvSpPr/>
           <p:nvPr/>
         </p:nvSpPr>
@@ -7891,7 +8092,7 @@
       </p:sp>
       <p:sp>
         <p:nvSpPr>
-          <p:cNvPr id="12" name="TextBox 11"/>
+          <p:cNvPr id="13" name="TextBox 12"/>
           <p:cNvSpPr txBox="1"/>
           <p:nvPr/>
         </p:nvSpPr>
@@ -7989,7 +8190,7 @@
       </p:sp>
       <p:sp>
         <p:nvSpPr>
-          <p:cNvPr id="13" name="Rounded Rectangle 12"/>
+          <p:cNvPr id="14" name="Rounded Rectangle 13"/>
           <p:cNvSpPr/>
           <p:nvPr/>
         </p:nvSpPr>
@@ -8034,7 +8235,7 @@
       </p:sp>
       <p:sp>
         <p:nvSpPr>
-          <p:cNvPr id="14" name="TextBox 13"/>
+          <p:cNvPr id="15" name="TextBox 14"/>
           <p:cNvSpPr txBox="1"/>
           <p:nvPr/>
         </p:nvSpPr>
@@ -8314,6 +8515,41 @@
         </p:nvSpPr>
         <p:spPr>
           <a:xfrm>
+            <a:off x="731520" y="6492240"/>
+            <a:ext cx="10728655" cy="320040"/>
+          </a:xfrm>
+          <a:prstGeom prst="rect">
+            <a:avLst/>
+          </a:prstGeom>
+          <a:noFill/>
+        </p:spPr>
+        <p:txBody>
+          <a:bodyPr wrap="none">
+            <a:spAutoFit/>
+          </a:bodyPr>
+          <a:lstStyle/>
+          <a:p>
+            <a:pPr>
+              <a:defRPr sz="950">
+                <a:solidFill>
+                  <a:srgbClr val="64748B"/>
+                </a:solidFill>
+              </a:defRPr>
+            </a:pPr>
+            <a:r>
+              <a:t>Dept of AI &amp; DS | RIT | Project Review - 1 | Team: DHANUSH MN (2117230070028), ASHWATHRAJ (2117230070017), ATHISH R (2117230070020)</a:t>
+            </a:r>
+          </a:p>
+        </p:txBody>
+      </p:sp>
+      <p:sp>
+        <p:nvSpPr>
+          <p:cNvPr id="7" name="TextBox 6"/>
+          <p:cNvSpPr txBox="1"/>
+          <p:nvPr/>
+        </p:nvSpPr>
+        <p:spPr>
+          <a:xfrm>
             <a:off x="731520" y="658368"/>
             <a:ext cx="10728655" cy="685800"/>
           </a:xfrm>
@@ -8355,7 +8591,7 @@
       </p:sp>
       <p:sp>
         <p:nvSpPr>
-          <p:cNvPr id="7" name="Rounded Rectangle 6"/>
+          <p:cNvPr id="8" name="Rounded Rectangle 7"/>
           <p:cNvSpPr/>
           <p:nvPr/>
         </p:nvSpPr>
@@ -8400,7 +8636,7 @@
       </p:sp>
       <p:sp>
         <p:nvSpPr>
-          <p:cNvPr id="8" name="TextBox 7"/>
+          <p:cNvPr id="9" name="TextBox 8"/>
           <p:cNvSpPr txBox="1"/>
           <p:nvPr/>
         </p:nvSpPr>
@@ -8483,7 +8719,7 @@
       </p:sp>
       <p:sp>
         <p:nvSpPr>
-          <p:cNvPr id="9" name="Rounded Rectangle 8"/>
+          <p:cNvPr id="10" name="Rounded Rectangle 9"/>
           <p:cNvSpPr/>
           <p:nvPr/>
         </p:nvSpPr>
@@ -8528,7 +8764,7 @@
       </p:sp>
       <p:sp>
         <p:nvSpPr>
-          <p:cNvPr id="10" name="TextBox 9"/>
+          <p:cNvPr id="11" name="TextBox 10"/>
           <p:cNvSpPr txBox="1"/>
           <p:nvPr/>
         </p:nvSpPr>
@@ -8611,7 +8847,7 @@
       </p:sp>
       <p:sp>
         <p:nvSpPr>
-          <p:cNvPr id="11" name="Rounded Rectangle 10"/>
+          <p:cNvPr id="12" name="Rounded Rectangle 11"/>
           <p:cNvSpPr/>
           <p:nvPr/>
         </p:nvSpPr>
@@ -8656,7 +8892,7 @@
       </p:sp>
       <p:sp>
         <p:nvSpPr>
-          <p:cNvPr id="12" name="TextBox 11"/>
+          <p:cNvPr id="13" name="TextBox 12"/>
           <p:cNvSpPr txBox="1"/>
           <p:nvPr/>
         </p:nvSpPr>
@@ -8739,7 +8975,7 @@
       </p:sp>
       <p:sp>
         <p:nvSpPr>
-          <p:cNvPr id="13" name="Rounded Rectangle 12"/>
+          <p:cNvPr id="14" name="Rounded Rectangle 13"/>
           <p:cNvSpPr/>
           <p:nvPr/>
         </p:nvSpPr>
@@ -8784,7 +9020,7 @@
       </p:sp>
       <p:sp>
         <p:nvSpPr>
-          <p:cNvPr id="14" name="TextBox 13"/>
+          <p:cNvPr id="15" name="TextBox 14"/>
           <p:cNvSpPr txBox="1"/>
           <p:nvPr/>
         </p:nvSpPr>
@@ -9049,6 +9285,41 @@
         </p:nvSpPr>
         <p:spPr>
           <a:xfrm>
+            <a:off x="731520" y="6492240"/>
+            <a:ext cx="10728655" cy="320040"/>
+          </a:xfrm>
+          <a:prstGeom prst="rect">
+            <a:avLst/>
+          </a:prstGeom>
+          <a:noFill/>
+        </p:spPr>
+        <p:txBody>
+          <a:bodyPr wrap="none">
+            <a:spAutoFit/>
+          </a:bodyPr>
+          <a:lstStyle/>
+          <a:p>
+            <a:pPr>
+              <a:defRPr sz="950">
+                <a:solidFill>
+                  <a:srgbClr val="64748B"/>
+                </a:solidFill>
+              </a:defRPr>
+            </a:pPr>
+            <a:r>
+              <a:t>Dept of AI &amp; DS | RIT | Project Review - 1 | Team: DHANUSH MN (2117230070028), ASHWATHRAJ (2117230070017), ATHISH R (2117230070020)</a:t>
+            </a:r>
+          </a:p>
+        </p:txBody>
+      </p:sp>
+      <p:sp>
+        <p:nvSpPr>
+          <p:cNvPr id="7" name="TextBox 6"/>
+          <p:cNvSpPr txBox="1"/>
+          <p:nvPr/>
+        </p:nvSpPr>
+        <p:spPr>
+          <a:xfrm>
             <a:off x="731520" y="658368"/>
             <a:ext cx="10728655" cy="685800"/>
           </a:xfrm>
@@ -9090,7 +9361,7 @@
       </p:sp>
       <p:sp>
         <p:nvSpPr>
-          <p:cNvPr id="7" name="Rounded Rectangle 6"/>
+          <p:cNvPr id="8" name="Rounded Rectangle 7"/>
           <p:cNvSpPr/>
           <p:nvPr/>
         </p:nvSpPr>
@@ -9135,7 +9406,7 @@
       </p:sp>
       <p:sp>
         <p:nvSpPr>
-          <p:cNvPr id="8" name="TextBox 7"/>
+          <p:cNvPr id="9" name="TextBox 8"/>
           <p:cNvSpPr txBox="1"/>
           <p:nvPr/>
         </p:nvSpPr>
@@ -9248,7 +9519,7 @@
       </p:sp>
       <p:sp>
         <p:nvSpPr>
-          <p:cNvPr id="9" name="Rounded Rectangle 8"/>
+          <p:cNvPr id="10" name="Rounded Rectangle 9"/>
           <p:cNvSpPr/>
           <p:nvPr/>
         </p:nvSpPr>
@@ -9293,7 +9564,7 @@
       </p:sp>
       <p:sp>
         <p:nvSpPr>
-          <p:cNvPr id="10" name="TextBox 9"/>
+          <p:cNvPr id="11" name="TextBox 10"/>
           <p:cNvSpPr txBox="1"/>
           <p:nvPr/>
         </p:nvSpPr>
@@ -9391,7 +9662,7 @@
       </p:sp>
       <p:sp>
         <p:nvSpPr>
-          <p:cNvPr id="11" name="Rounded Rectangle 10"/>
+          <p:cNvPr id="12" name="Rounded Rectangle 11"/>
           <p:cNvSpPr/>
           <p:nvPr/>
         </p:nvSpPr>
@@ -9436,7 +9707,7 @@
       </p:sp>
       <p:sp>
         <p:nvSpPr>
-          <p:cNvPr id="12" name="TextBox 11"/>
+          <p:cNvPr id="13" name="TextBox 12"/>
           <p:cNvSpPr txBox="1"/>
           <p:nvPr/>
         </p:nvSpPr>
@@ -9716,6 +9987,41 @@
         </p:nvSpPr>
         <p:spPr>
           <a:xfrm>
+            <a:off x="731520" y="6492240"/>
+            <a:ext cx="10728655" cy="320040"/>
+          </a:xfrm>
+          <a:prstGeom prst="rect">
+            <a:avLst/>
+          </a:prstGeom>
+          <a:noFill/>
+        </p:spPr>
+        <p:txBody>
+          <a:bodyPr wrap="none">
+            <a:spAutoFit/>
+          </a:bodyPr>
+          <a:lstStyle/>
+          <a:p>
+            <a:pPr>
+              <a:defRPr sz="950">
+                <a:solidFill>
+                  <a:srgbClr val="64748B"/>
+                </a:solidFill>
+              </a:defRPr>
+            </a:pPr>
+            <a:r>
+              <a:t>Dept of AI &amp; DS | RIT | Project Review - 1 | Team: DHANUSH MN (2117230070028), ASHWATHRAJ (2117230070017), ATHISH R (2117230070020)</a:t>
+            </a:r>
+          </a:p>
+        </p:txBody>
+      </p:sp>
+      <p:sp>
+        <p:nvSpPr>
+          <p:cNvPr id="7" name="TextBox 6"/>
+          <p:cNvSpPr txBox="1"/>
+          <p:nvPr/>
+        </p:nvSpPr>
+        <p:spPr>
+          <a:xfrm>
             <a:off x="731520" y="658368"/>
             <a:ext cx="10728655" cy="685800"/>
           </a:xfrm>
@@ -9757,7 +10063,7 @@
       </p:sp>
       <p:sp>
         <p:nvSpPr>
-          <p:cNvPr id="7" name="Rounded Rectangle 6"/>
+          <p:cNvPr id="8" name="Rounded Rectangle 7"/>
           <p:cNvSpPr/>
           <p:nvPr/>
         </p:nvSpPr>
@@ -9802,7 +10108,7 @@
       </p:sp>
       <p:sp>
         <p:nvSpPr>
-          <p:cNvPr id="8" name="TextBox 7"/>
+          <p:cNvPr id="9" name="TextBox 8"/>
           <p:cNvSpPr txBox="1"/>
           <p:nvPr/>
         </p:nvSpPr>
@@ -9915,7 +10221,7 @@
       </p:sp>
       <p:sp>
         <p:nvSpPr>
-          <p:cNvPr id="9" name="Rounded Rectangle 8"/>
+          <p:cNvPr id="10" name="Rounded Rectangle 9"/>
           <p:cNvSpPr/>
           <p:nvPr/>
         </p:nvSpPr>
@@ -9960,7 +10266,7 @@
       </p:sp>
       <p:sp>
         <p:nvSpPr>
-          <p:cNvPr id="10" name="TextBox 9"/>
+          <p:cNvPr id="11" name="TextBox 10"/>
           <p:cNvSpPr txBox="1"/>
           <p:nvPr/>
         </p:nvSpPr>
@@ -10240,6 +10546,41 @@
         </p:nvSpPr>
         <p:spPr>
           <a:xfrm>
+            <a:off x="731520" y="6492240"/>
+            <a:ext cx="10728655" cy="320040"/>
+          </a:xfrm>
+          <a:prstGeom prst="rect">
+            <a:avLst/>
+          </a:prstGeom>
+          <a:noFill/>
+        </p:spPr>
+        <p:txBody>
+          <a:bodyPr wrap="none">
+            <a:spAutoFit/>
+          </a:bodyPr>
+          <a:lstStyle/>
+          <a:p>
+            <a:pPr>
+              <a:defRPr sz="950">
+                <a:solidFill>
+                  <a:srgbClr val="64748B"/>
+                </a:solidFill>
+              </a:defRPr>
+            </a:pPr>
+            <a:r>
+              <a:t>Dept of AI &amp; DS | RIT | Project Review - 1 | Team: DHANUSH MN (2117230070028), ASHWATHRAJ (2117230070017), ATHISH R (2117230070020)</a:t>
+            </a:r>
+          </a:p>
+        </p:txBody>
+      </p:sp>
+      <p:sp>
+        <p:nvSpPr>
+          <p:cNvPr id="7" name="TextBox 6"/>
+          <p:cNvSpPr txBox="1"/>
+          <p:nvPr/>
+        </p:nvSpPr>
+        <p:spPr>
+          <a:xfrm>
             <a:off x="731520" y="658368"/>
             <a:ext cx="10728655" cy="685800"/>
           </a:xfrm>
@@ -10281,7 +10622,7 @@
       </p:sp>
       <p:sp>
         <p:nvSpPr>
-          <p:cNvPr id="7" name="Rounded Rectangle 6"/>
+          <p:cNvPr id="8" name="Rounded Rectangle 7"/>
           <p:cNvSpPr/>
           <p:nvPr/>
         </p:nvSpPr>
@@ -10326,7 +10667,7 @@
       </p:sp>
       <p:sp>
         <p:nvSpPr>
-          <p:cNvPr id="8" name="TextBox 7"/>
+          <p:cNvPr id="9" name="TextBox 8"/>
           <p:cNvSpPr txBox="1"/>
           <p:nvPr/>
         </p:nvSpPr>
@@ -10469,7 +10810,7 @@
       </p:sp>
       <p:sp>
         <p:nvSpPr>
-          <p:cNvPr id="9" name="Rounded Rectangle 8"/>
+          <p:cNvPr id="10" name="Rounded Rectangle 9"/>
           <p:cNvSpPr/>
           <p:nvPr/>
         </p:nvSpPr>
@@ -10514,7 +10855,7 @@
       </p:sp>
       <p:sp>
         <p:nvSpPr>
-          <p:cNvPr id="10" name="TextBox 9"/>
+          <p:cNvPr id="11" name="TextBox 10"/>
           <p:cNvSpPr txBox="1"/>
           <p:nvPr/>
         </p:nvSpPr>
@@ -10854,6 +11195,41 @@
         </p:nvSpPr>
         <p:spPr>
           <a:xfrm>
+            <a:off x="731520" y="6492240"/>
+            <a:ext cx="10728655" cy="320040"/>
+          </a:xfrm>
+          <a:prstGeom prst="rect">
+            <a:avLst/>
+          </a:prstGeom>
+          <a:noFill/>
+        </p:spPr>
+        <p:txBody>
+          <a:bodyPr wrap="none">
+            <a:spAutoFit/>
+          </a:bodyPr>
+          <a:lstStyle/>
+          <a:p>
+            <a:pPr>
+              <a:defRPr sz="950">
+                <a:solidFill>
+                  <a:srgbClr val="64748B"/>
+                </a:solidFill>
+              </a:defRPr>
+            </a:pPr>
+            <a:r>
+              <a:t>Dept of AI &amp; DS | RIT | Project Review - 1 | Team: DHANUSH MN (2117230070028), ASHWATHRAJ (2117230070017), ATHISH R (2117230070020)</a:t>
+            </a:r>
+          </a:p>
+        </p:txBody>
+      </p:sp>
+      <p:sp>
+        <p:nvSpPr>
+          <p:cNvPr id="7" name="TextBox 6"/>
+          <p:cNvSpPr txBox="1"/>
+          <p:nvPr/>
+        </p:nvSpPr>
+        <p:spPr>
+          <a:xfrm>
             <a:off x="731520" y="658368"/>
             <a:ext cx="10728655" cy="685800"/>
           </a:xfrm>
@@ -10895,7 +11271,7 @@
       </p:sp>
       <p:sp>
         <p:nvSpPr>
-          <p:cNvPr id="7" name="Rounded Rectangle 6"/>
+          <p:cNvPr id="8" name="Rounded Rectangle 7"/>
           <p:cNvSpPr/>
           <p:nvPr/>
         </p:nvSpPr>
@@ -10940,7 +11316,7 @@
       </p:sp>
       <p:sp>
         <p:nvSpPr>
-          <p:cNvPr id="8" name="TextBox 7"/>
+          <p:cNvPr id="9" name="TextBox 8"/>
           <p:cNvSpPr txBox="1"/>
           <p:nvPr/>
         </p:nvSpPr>
@@ -11038,7 +11414,7 @@
       </p:sp>
       <p:sp>
         <p:nvSpPr>
-          <p:cNvPr id="9" name="Rounded Rectangle 8"/>
+          <p:cNvPr id="10" name="Rounded Rectangle 9"/>
           <p:cNvSpPr/>
           <p:nvPr/>
         </p:nvSpPr>
@@ -11083,7 +11459,7 @@
       </p:sp>
       <p:sp>
         <p:nvSpPr>
-          <p:cNvPr id="10" name="TextBox 9"/>
+          <p:cNvPr id="11" name="TextBox 10"/>
           <p:cNvSpPr txBox="1"/>
           <p:nvPr/>
         </p:nvSpPr>
@@ -11363,6 +11739,41 @@
         </p:nvSpPr>
         <p:spPr>
           <a:xfrm>
+            <a:off x="731520" y="6492240"/>
+            <a:ext cx="10728655" cy="320040"/>
+          </a:xfrm>
+          <a:prstGeom prst="rect">
+            <a:avLst/>
+          </a:prstGeom>
+          <a:noFill/>
+        </p:spPr>
+        <p:txBody>
+          <a:bodyPr wrap="none">
+            <a:spAutoFit/>
+          </a:bodyPr>
+          <a:lstStyle/>
+          <a:p>
+            <a:pPr>
+              <a:defRPr sz="950">
+                <a:solidFill>
+                  <a:srgbClr val="64748B"/>
+                </a:solidFill>
+              </a:defRPr>
+            </a:pPr>
+            <a:r>
+              <a:t>Dept of AI &amp; DS | RIT | Project Review - 1 | Team: DHANUSH MN (2117230070028), ASHWATHRAJ (2117230070017), ATHISH R (2117230070020)</a:t>
+            </a:r>
+          </a:p>
+        </p:txBody>
+      </p:sp>
+      <p:sp>
+        <p:nvSpPr>
+          <p:cNvPr id="7" name="TextBox 6"/>
+          <p:cNvSpPr txBox="1"/>
+          <p:nvPr/>
+        </p:nvSpPr>
+        <p:spPr>
+          <a:xfrm>
             <a:off x="731520" y="658368"/>
             <a:ext cx="10728655" cy="685800"/>
           </a:xfrm>
@@ -11404,7 +11815,7 @@
       </p:sp>
       <p:sp>
         <p:nvSpPr>
-          <p:cNvPr id="7" name="Rounded Rectangle 6"/>
+          <p:cNvPr id="8" name="Rounded Rectangle 7"/>
           <p:cNvSpPr/>
           <p:nvPr/>
         </p:nvSpPr>
@@ -11449,7 +11860,7 @@
       </p:sp>
       <p:sp>
         <p:nvSpPr>
-          <p:cNvPr id="8" name="TextBox 7"/>
+          <p:cNvPr id="9" name="TextBox 8"/>
           <p:cNvSpPr txBox="1"/>
           <p:nvPr/>
         </p:nvSpPr>
@@ -11547,7 +11958,7 @@
       </p:sp>
       <p:sp>
         <p:nvSpPr>
-          <p:cNvPr id="9" name="Rounded Rectangle 8"/>
+          <p:cNvPr id="10" name="Rounded Rectangle 9"/>
           <p:cNvSpPr/>
           <p:nvPr/>
         </p:nvSpPr>
@@ -11592,7 +12003,7 @@
       </p:sp>
       <p:sp>
         <p:nvSpPr>
-          <p:cNvPr id="10" name="TextBox 9"/>
+          <p:cNvPr id="11" name="TextBox 10"/>
           <p:cNvSpPr txBox="1"/>
           <p:nvPr/>
         </p:nvSpPr>
@@ -11872,6 +12283,41 @@
         </p:nvSpPr>
         <p:spPr>
           <a:xfrm>
+            <a:off x="731520" y="6492240"/>
+            <a:ext cx="10728655" cy="320040"/>
+          </a:xfrm>
+          <a:prstGeom prst="rect">
+            <a:avLst/>
+          </a:prstGeom>
+          <a:noFill/>
+        </p:spPr>
+        <p:txBody>
+          <a:bodyPr wrap="none">
+            <a:spAutoFit/>
+          </a:bodyPr>
+          <a:lstStyle/>
+          <a:p>
+            <a:pPr>
+              <a:defRPr sz="950">
+                <a:solidFill>
+                  <a:srgbClr val="64748B"/>
+                </a:solidFill>
+              </a:defRPr>
+            </a:pPr>
+            <a:r>
+              <a:t>Dept of AI &amp; DS | RIT | Project Review - 1 | Team: DHANUSH MN (2117230070028), ASHWATHRAJ (2117230070017), ATHISH R (2117230070020)</a:t>
+            </a:r>
+          </a:p>
+        </p:txBody>
+      </p:sp>
+      <p:sp>
+        <p:nvSpPr>
+          <p:cNvPr id="7" name="TextBox 6"/>
+          <p:cNvSpPr txBox="1"/>
+          <p:nvPr/>
+        </p:nvSpPr>
+        <p:spPr>
+          <a:xfrm>
             <a:off x="731520" y="658368"/>
             <a:ext cx="10728655" cy="685800"/>
           </a:xfrm>
@@ -11913,7 +12359,7 @@
       </p:sp>
       <p:sp>
         <p:nvSpPr>
-          <p:cNvPr id="7" name="Rounded Rectangle 6"/>
+          <p:cNvPr id="8" name="Rounded Rectangle 7"/>
           <p:cNvSpPr/>
           <p:nvPr/>
         </p:nvSpPr>
@@ -11958,7 +12404,7 @@
       </p:sp>
       <p:sp>
         <p:nvSpPr>
-          <p:cNvPr id="8" name="TextBox 7"/>
+          <p:cNvPr id="9" name="TextBox 8"/>
           <p:cNvSpPr txBox="1"/>
           <p:nvPr/>
         </p:nvSpPr>
@@ -12041,7 +12487,7 @@
       </p:sp>
       <p:sp>
         <p:nvSpPr>
-          <p:cNvPr id="9" name="Rounded Rectangle 8"/>
+          <p:cNvPr id="10" name="Rounded Rectangle 9"/>
           <p:cNvSpPr/>
           <p:nvPr/>
         </p:nvSpPr>
@@ -12086,7 +12532,7 @@
       </p:sp>
       <p:sp>
         <p:nvSpPr>
-          <p:cNvPr id="10" name="TextBox 9"/>
+          <p:cNvPr id="11" name="TextBox 10"/>
           <p:cNvSpPr txBox="1"/>
           <p:nvPr/>
         </p:nvSpPr>
@@ -12169,7 +12615,7 @@
       </p:sp>
       <p:sp>
         <p:nvSpPr>
-          <p:cNvPr id="11" name="Rounded Rectangle 10"/>
+          <p:cNvPr id="12" name="Rounded Rectangle 11"/>
           <p:cNvSpPr/>
           <p:nvPr/>
         </p:nvSpPr>
@@ -12214,7 +12660,7 @@
       </p:sp>
       <p:sp>
         <p:nvSpPr>
-          <p:cNvPr id="12" name="TextBox 11"/>
+          <p:cNvPr id="13" name="TextBox 12"/>
           <p:cNvSpPr txBox="1"/>
           <p:nvPr/>
         </p:nvSpPr>
@@ -12297,7 +12743,7 @@
       </p:sp>
       <p:sp>
         <p:nvSpPr>
-          <p:cNvPr id="13" name="Rounded Rectangle 12"/>
+          <p:cNvPr id="14" name="Rounded Rectangle 13"/>
           <p:cNvSpPr/>
           <p:nvPr/>
         </p:nvSpPr>
@@ -12342,7 +12788,7 @@
       </p:sp>
       <p:sp>
         <p:nvSpPr>
-          <p:cNvPr id="14" name="TextBox 13"/>
+          <p:cNvPr id="15" name="TextBox 14"/>
           <p:cNvSpPr txBox="1"/>
           <p:nvPr/>
         </p:nvSpPr>
@@ -12607,6 +13053,41 @@
         </p:nvSpPr>
         <p:spPr>
           <a:xfrm>
+            <a:off x="731520" y="6492240"/>
+            <a:ext cx="10728655" cy="320040"/>
+          </a:xfrm>
+          <a:prstGeom prst="rect">
+            <a:avLst/>
+          </a:prstGeom>
+          <a:noFill/>
+        </p:spPr>
+        <p:txBody>
+          <a:bodyPr wrap="none">
+            <a:spAutoFit/>
+          </a:bodyPr>
+          <a:lstStyle/>
+          <a:p>
+            <a:pPr>
+              <a:defRPr sz="950">
+                <a:solidFill>
+                  <a:srgbClr val="64748B"/>
+                </a:solidFill>
+              </a:defRPr>
+            </a:pPr>
+            <a:r>
+              <a:t>Dept of AI &amp; DS | RIT | Project Review - 1 | Team: DHANUSH MN (2117230070028), ASHWATHRAJ (2117230070017), ATHISH R (2117230070020)</a:t>
+            </a:r>
+          </a:p>
+        </p:txBody>
+      </p:sp>
+      <p:sp>
+        <p:nvSpPr>
+          <p:cNvPr id="7" name="TextBox 6"/>
+          <p:cNvSpPr txBox="1"/>
+          <p:nvPr/>
+        </p:nvSpPr>
+        <p:spPr>
+          <a:xfrm>
             <a:off x="731520" y="658368"/>
             <a:ext cx="10728655" cy="685800"/>
           </a:xfrm>
@@ -12648,7 +13129,7 @@
       </p:sp>
       <p:sp>
         <p:nvSpPr>
-          <p:cNvPr id="7" name="Rounded Rectangle 6"/>
+          <p:cNvPr id="8" name="Rounded Rectangle 7"/>
           <p:cNvSpPr/>
           <p:nvPr/>
         </p:nvSpPr>
@@ -12693,7 +13174,7 @@
       </p:sp>
       <p:sp>
         <p:nvSpPr>
-          <p:cNvPr id="8" name="TextBox 7"/>
+          <p:cNvPr id="9" name="TextBox 8"/>
           <p:cNvSpPr txBox="1"/>
           <p:nvPr/>
         </p:nvSpPr>
@@ -12746,7 +13227,7 @@
       </p:sp>
       <p:sp>
         <p:nvSpPr>
-          <p:cNvPr id="9" name="Rounded Rectangle 8"/>
+          <p:cNvPr id="10" name="Rounded Rectangle 9"/>
           <p:cNvSpPr/>
           <p:nvPr/>
         </p:nvSpPr>
@@ -12791,7 +13272,7 @@
       </p:sp>
       <p:sp>
         <p:nvSpPr>
-          <p:cNvPr id="10" name="TextBox 9"/>
+          <p:cNvPr id="11" name="TextBox 10"/>
           <p:cNvSpPr txBox="1"/>
           <p:nvPr/>
         </p:nvSpPr>
@@ -12919,7 +13400,7 @@
       </p:sp>
       <p:sp>
         <p:nvSpPr>
-          <p:cNvPr id="11" name="Rounded Rectangle 10"/>
+          <p:cNvPr id="12" name="Rounded Rectangle 11"/>
           <p:cNvSpPr/>
           <p:nvPr/>
         </p:nvSpPr>
@@ -12964,7 +13445,7 @@
       </p:sp>
       <p:sp>
         <p:nvSpPr>
-          <p:cNvPr id="12" name="TextBox 11"/>
+          <p:cNvPr id="13" name="TextBox 12"/>
           <p:cNvSpPr txBox="1"/>
           <p:nvPr/>
         </p:nvSpPr>
@@ -13259,6 +13740,41 @@
         </p:nvSpPr>
         <p:spPr>
           <a:xfrm>
+            <a:off x="731520" y="6492240"/>
+            <a:ext cx="10728655" cy="320040"/>
+          </a:xfrm>
+          <a:prstGeom prst="rect">
+            <a:avLst/>
+          </a:prstGeom>
+          <a:noFill/>
+        </p:spPr>
+        <p:txBody>
+          <a:bodyPr wrap="none">
+            <a:spAutoFit/>
+          </a:bodyPr>
+          <a:lstStyle/>
+          <a:p>
+            <a:pPr>
+              <a:defRPr sz="950">
+                <a:solidFill>
+                  <a:srgbClr val="64748B"/>
+                </a:solidFill>
+              </a:defRPr>
+            </a:pPr>
+            <a:r>
+              <a:t>Dept of AI &amp; DS | RIT | Project Review - 1 | Team: DHANUSH MN (2117230070028), ASHWATHRAJ (2117230070017), ATHISH R (2117230070020)</a:t>
+            </a:r>
+          </a:p>
+        </p:txBody>
+      </p:sp>
+      <p:sp>
+        <p:nvSpPr>
+          <p:cNvPr id="7" name="TextBox 6"/>
+          <p:cNvSpPr txBox="1"/>
+          <p:nvPr/>
+        </p:nvSpPr>
+        <p:spPr>
+          <a:xfrm>
             <a:off x="731520" y="658368"/>
             <a:ext cx="10728655" cy="685800"/>
           </a:xfrm>
@@ -13300,7 +13816,7 @@
       </p:sp>
       <p:sp>
         <p:nvSpPr>
-          <p:cNvPr id="7" name="Rounded Rectangle 6"/>
+          <p:cNvPr id="8" name="Rounded Rectangle 7"/>
           <p:cNvSpPr/>
           <p:nvPr/>
         </p:nvSpPr>
@@ -13345,7 +13861,7 @@
       </p:sp>
       <p:sp>
         <p:nvSpPr>
-          <p:cNvPr id="8" name="TextBox 7"/>
+          <p:cNvPr id="9" name="TextBox 8"/>
           <p:cNvSpPr txBox="1"/>
           <p:nvPr/>
         </p:nvSpPr>
@@ -13428,7 +13944,7 @@
       </p:sp>
       <p:sp>
         <p:nvSpPr>
-          <p:cNvPr id="9" name="Rounded Rectangle 8"/>
+          <p:cNvPr id="10" name="Rounded Rectangle 9"/>
           <p:cNvSpPr/>
           <p:nvPr/>
         </p:nvSpPr>
@@ -13473,7 +13989,7 @@
       </p:sp>
       <p:sp>
         <p:nvSpPr>
-          <p:cNvPr id="10" name="TextBox 9"/>
+          <p:cNvPr id="11" name="TextBox 10"/>
           <p:cNvSpPr txBox="1"/>
           <p:nvPr/>
         </p:nvSpPr>
@@ -13556,7 +14072,7 @@
       </p:sp>
       <p:sp>
         <p:nvSpPr>
-          <p:cNvPr id="11" name="Rounded Rectangle 10"/>
+          <p:cNvPr id="12" name="Rounded Rectangle 11"/>
           <p:cNvSpPr/>
           <p:nvPr/>
         </p:nvSpPr>
@@ -13601,7 +14117,7 @@
       </p:sp>
       <p:sp>
         <p:nvSpPr>
-          <p:cNvPr id="12" name="TextBox 11"/>
+          <p:cNvPr id="13" name="TextBox 12"/>
           <p:cNvSpPr txBox="1"/>
           <p:nvPr/>
         </p:nvSpPr>
@@ -13684,7 +14200,7 @@
       </p:sp>
       <p:sp>
         <p:nvSpPr>
-          <p:cNvPr id="13" name="Rounded Rectangle 12"/>
+          <p:cNvPr id="14" name="Rounded Rectangle 13"/>
           <p:cNvSpPr/>
           <p:nvPr/>
         </p:nvSpPr>
@@ -13729,7 +14245,7 @@
       </p:sp>
       <p:sp>
         <p:nvSpPr>
-          <p:cNvPr id="14" name="TextBox 13"/>
+          <p:cNvPr id="15" name="TextBox 14"/>
           <p:cNvSpPr txBox="1"/>
           <p:nvPr/>
         </p:nvSpPr>
@@ -13994,6 +14510,41 @@
         </p:nvSpPr>
         <p:spPr>
           <a:xfrm>
+            <a:off x="731520" y="6492240"/>
+            <a:ext cx="10728655" cy="320040"/>
+          </a:xfrm>
+          <a:prstGeom prst="rect">
+            <a:avLst/>
+          </a:prstGeom>
+          <a:noFill/>
+        </p:spPr>
+        <p:txBody>
+          <a:bodyPr wrap="none">
+            <a:spAutoFit/>
+          </a:bodyPr>
+          <a:lstStyle/>
+          <a:p>
+            <a:pPr>
+              <a:defRPr sz="950">
+                <a:solidFill>
+                  <a:srgbClr val="64748B"/>
+                </a:solidFill>
+              </a:defRPr>
+            </a:pPr>
+            <a:r>
+              <a:t>Dept of AI &amp; DS | RIT | Project Review - 1 | Team: DHANUSH MN (2117230070028), ASHWATHRAJ (2117230070017), ATHISH R (2117230070020)</a:t>
+            </a:r>
+          </a:p>
+        </p:txBody>
+      </p:sp>
+      <p:sp>
+        <p:nvSpPr>
+          <p:cNvPr id="7" name="TextBox 6"/>
+          <p:cNvSpPr txBox="1"/>
+          <p:nvPr/>
+        </p:nvSpPr>
+        <p:spPr>
+          <a:xfrm>
             <a:off x="731520" y="658368"/>
             <a:ext cx="10728655" cy="685800"/>
           </a:xfrm>
@@ -14035,7 +14586,7 @@
       </p:sp>
       <p:sp>
         <p:nvSpPr>
-          <p:cNvPr id="7" name="Rounded Rectangle 6"/>
+          <p:cNvPr id="8" name="Rounded Rectangle 7"/>
           <p:cNvSpPr/>
           <p:nvPr/>
         </p:nvSpPr>
@@ -14080,7 +14631,7 @@
       </p:sp>
       <p:sp>
         <p:nvSpPr>
-          <p:cNvPr id="8" name="TextBox 7"/>
+          <p:cNvPr id="9" name="TextBox 8"/>
           <p:cNvSpPr txBox="1"/>
           <p:nvPr/>
         </p:nvSpPr>
@@ -14178,7 +14729,7 @@
       </p:sp>
       <p:sp>
         <p:nvSpPr>
-          <p:cNvPr id="9" name="Rounded Rectangle 8"/>
+          <p:cNvPr id="10" name="Rounded Rectangle 9"/>
           <p:cNvSpPr/>
           <p:nvPr/>
         </p:nvSpPr>
@@ -14223,7 +14774,7 @@
       </p:sp>
       <p:sp>
         <p:nvSpPr>
-          <p:cNvPr id="10" name="TextBox 9"/>
+          <p:cNvPr id="11" name="TextBox 10"/>
           <p:cNvSpPr txBox="1"/>
           <p:nvPr/>
         </p:nvSpPr>
@@ -14503,6 +15054,41 @@
         </p:nvSpPr>
         <p:spPr>
           <a:xfrm>
+            <a:off x="731520" y="6492240"/>
+            <a:ext cx="10728655" cy="320040"/>
+          </a:xfrm>
+          <a:prstGeom prst="rect">
+            <a:avLst/>
+          </a:prstGeom>
+          <a:noFill/>
+        </p:spPr>
+        <p:txBody>
+          <a:bodyPr wrap="none">
+            <a:spAutoFit/>
+          </a:bodyPr>
+          <a:lstStyle/>
+          <a:p>
+            <a:pPr>
+              <a:defRPr sz="950">
+                <a:solidFill>
+                  <a:srgbClr val="64748B"/>
+                </a:solidFill>
+              </a:defRPr>
+            </a:pPr>
+            <a:r>
+              <a:t>Dept of AI &amp; DS | RIT | Project Review - 1 | Team: DHANUSH MN (2117230070028), ASHWATHRAJ (2117230070017), ATHISH R (2117230070020)</a:t>
+            </a:r>
+          </a:p>
+        </p:txBody>
+      </p:sp>
+      <p:sp>
+        <p:nvSpPr>
+          <p:cNvPr id="7" name="TextBox 6"/>
+          <p:cNvSpPr txBox="1"/>
+          <p:nvPr/>
+        </p:nvSpPr>
+        <p:spPr>
+          <a:xfrm>
             <a:off x="731520" y="658368"/>
             <a:ext cx="10728655" cy="685800"/>
           </a:xfrm>
@@ -14544,7 +15130,7 @@
       </p:sp>
       <p:sp>
         <p:nvSpPr>
-          <p:cNvPr id="7" name="Rounded Rectangle 6"/>
+          <p:cNvPr id="8" name="Rounded Rectangle 7"/>
           <p:cNvSpPr/>
           <p:nvPr/>
         </p:nvSpPr>
@@ -14589,7 +15175,7 @@
       </p:sp>
       <p:sp>
         <p:nvSpPr>
-          <p:cNvPr id="8" name="TextBox 7"/>
+          <p:cNvPr id="9" name="TextBox 8"/>
           <p:cNvSpPr txBox="1"/>
           <p:nvPr/>
         </p:nvSpPr>
@@ -14672,7 +15258,7 @@
       </p:sp>
       <p:sp>
         <p:nvSpPr>
-          <p:cNvPr id="9" name="Rounded Rectangle 8"/>
+          <p:cNvPr id="10" name="Rounded Rectangle 9"/>
           <p:cNvSpPr/>
           <p:nvPr/>
         </p:nvSpPr>
@@ -14717,7 +15303,7 @@
       </p:sp>
       <p:sp>
         <p:nvSpPr>
-          <p:cNvPr id="10" name="TextBox 9"/>
+          <p:cNvPr id="11" name="TextBox 10"/>
           <p:cNvSpPr txBox="1"/>
           <p:nvPr/>
         </p:nvSpPr>
@@ -14800,7 +15386,7 @@
       </p:sp>
       <p:sp>
         <p:nvSpPr>
-          <p:cNvPr id="11" name="Rounded Rectangle 10"/>
+          <p:cNvPr id="12" name="Rounded Rectangle 11"/>
           <p:cNvSpPr/>
           <p:nvPr/>
         </p:nvSpPr>
@@ -14845,7 +15431,7 @@
       </p:sp>
       <p:sp>
         <p:nvSpPr>
-          <p:cNvPr id="12" name="TextBox 11"/>
+          <p:cNvPr id="13" name="TextBox 12"/>
           <p:cNvSpPr txBox="1"/>
           <p:nvPr/>
         </p:nvSpPr>
@@ -14928,7 +15514,7 @@
       </p:sp>
       <p:sp>
         <p:nvSpPr>
-          <p:cNvPr id="13" name="Rounded Rectangle 12"/>
+          <p:cNvPr id="14" name="Rounded Rectangle 13"/>
           <p:cNvSpPr/>
           <p:nvPr/>
         </p:nvSpPr>
@@ -14973,7 +15559,7 @@
       </p:sp>
       <p:sp>
         <p:nvSpPr>
-          <p:cNvPr id="14" name="TextBox 13"/>
+          <p:cNvPr id="15" name="TextBox 14"/>
           <p:cNvSpPr txBox="1"/>
           <p:nvPr/>
         </p:nvSpPr>

</xml_diff>

<commit_message>
Update project title to STUDENTS ATTENDANCE MONITORING SYSTEM across presentations and base papers
</commit_message>
<xml_diff>
--- a/SMART_ATTENDANCE_MONITORING.pptx
+++ b/SMART_ATTENDANCE_MONITORING.pptx
@@ -1047,7 +1047,7 @@
           </a:p>
           <a:p>
             <a:r>
-              <a:t>'In conclusion: The Smart Attendance Monitoring System saves time, stops proxy attendance, and automates daily reporting using deep learning face recognition. I have already built and verified the working prototype for Phase 1. Thank you respected staff and panel members, I am ready for your questions and guidance!'</a:t>
+              <a:t>'In conclusion: The Student Attendance Monitoring System saves time, stops proxy attendance, and automates daily reporting using deep learning face recognition. We have already built and verified the working prototype for Phase 1. Thank you respected staff and panel members, we are ready for your questions and guidance!'</a:t>
             </a:r>
           </a:p>
         </p:txBody>
@@ -4879,7 +4879,7 @@
               </a:defRPr>
             </a:pPr>
             <a:r>
-              <a:t>SMART ATTENDANCE MONITORING SYSTEM</a:t>
+              <a:t>STUDENT ATTENDANCE MONITORING SYSTEM</a:t>
             </a:r>
           </a:p>
           <a:p>

</xml_diff>